<commit_message>
wrapping op custom playlists, with a bug fix for generating compileStrings
</commit_message>
<xml_diff>
--- a/Design Log/DJ deck.pptx
+++ b/Design Log/DJ deck.pptx
@@ -223,7 +223,7 @@
           <a:p>
             <a:fld id="{F2131A79-E1C2-43E2-88BB-991A587CF34B}" type="datetimeFigureOut">
               <a:rPr lang="nl-NL" smtClean="0"/>
-              <a:t>15-5-2025</a:t>
+              <a:t>19-5-2025</a:t>
             </a:fld>
             <a:endParaRPr lang="nl-NL"/>
           </a:p>
@@ -724,7 +724,7 @@
           <a:p>
             <a:fld id="{291A462F-E04C-4E22-938A-A0EF93E33BE5}" type="datetimeFigureOut">
               <a:rPr lang="nl-NL" smtClean="0"/>
-              <a:t>15-5-2025</a:t>
+              <a:t>19-5-2025</a:t>
             </a:fld>
             <a:endParaRPr lang="nl-NL"/>
           </a:p>
@@ -924,7 +924,7 @@
           <a:p>
             <a:fld id="{291A462F-E04C-4E22-938A-A0EF93E33BE5}" type="datetimeFigureOut">
               <a:rPr lang="nl-NL" smtClean="0"/>
-              <a:t>15-5-2025</a:t>
+              <a:t>19-5-2025</a:t>
             </a:fld>
             <a:endParaRPr lang="nl-NL"/>
           </a:p>
@@ -1134,7 +1134,7 @@
           <a:p>
             <a:fld id="{291A462F-E04C-4E22-938A-A0EF93E33BE5}" type="datetimeFigureOut">
               <a:rPr lang="nl-NL" smtClean="0"/>
-              <a:t>15-5-2025</a:t>
+              <a:t>19-5-2025</a:t>
             </a:fld>
             <a:endParaRPr lang="nl-NL"/>
           </a:p>
@@ -1334,7 +1334,7 @@
           <a:p>
             <a:fld id="{291A462F-E04C-4E22-938A-A0EF93E33BE5}" type="datetimeFigureOut">
               <a:rPr lang="nl-NL" smtClean="0"/>
-              <a:t>15-5-2025</a:t>
+              <a:t>19-5-2025</a:t>
             </a:fld>
             <a:endParaRPr lang="nl-NL"/>
           </a:p>
@@ -1610,7 +1610,7 @@
           <a:p>
             <a:fld id="{291A462F-E04C-4E22-938A-A0EF93E33BE5}" type="datetimeFigureOut">
               <a:rPr lang="nl-NL" smtClean="0"/>
-              <a:t>15-5-2025</a:t>
+              <a:t>19-5-2025</a:t>
             </a:fld>
             <a:endParaRPr lang="nl-NL"/>
           </a:p>
@@ -1878,7 +1878,7 @@
           <a:p>
             <a:fld id="{291A462F-E04C-4E22-938A-A0EF93E33BE5}" type="datetimeFigureOut">
               <a:rPr lang="nl-NL" smtClean="0"/>
-              <a:t>15-5-2025</a:t>
+              <a:t>19-5-2025</a:t>
             </a:fld>
             <a:endParaRPr lang="nl-NL"/>
           </a:p>
@@ -2293,7 +2293,7 @@
           <a:p>
             <a:fld id="{291A462F-E04C-4E22-938A-A0EF93E33BE5}" type="datetimeFigureOut">
               <a:rPr lang="nl-NL" smtClean="0"/>
-              <a:t>15-5-2025</a:t>
+              <a:t>19-5-2025</a:t>
             </a:fld>
             <a:endParaRPr lang="nl-NL"/>
           </a:p>
@@ -2435,7 +2435,7 @@
           <a:p>
             <a:fld id="{291A462F-E04C-4E22-938A-A0EF93E33BE5}" type="datetimeFigureOut">
               <a:rPr lang="nl-NL" smtClean="0"/>
-              <a:t>15-5-2025</a:t>
+              <a:t>19-5-2025</a:t>
             </a:fld>
             <a:endParaRPr lang="nl-NL"/>
           </a:p>
@@ -2548,7 +2548,7 @@
           <a:p>
             <a:fld id="{291A462F-E04C-4E22-938A-A0EF93E33BE5}" type="datetimeFigureOut">
               <a:rPr lang="nl-NL" smtClean="0"/>
-              <a:t>15-5-2025</a:t>
+              <a:t>19-5-2025</a:t>
             </a:fld>
             <a:endParaRPr lang="nl-NL"/>
           </a:p>
@@ -2861,7 +2861,7 @@
           <a:p>
             <a:fld id="{291A462F-E04C-4E22-938A-A0EF93E33BE5}" type="datetimeFigureOut">
               <a:rPr lang="nl-NL" smtClean="0"/>
-              <a:t>15-5-2025</a:t>
+              <a:t>19-5-2025</a:t>
             </a:fld>
             <a:endParaRPr lang="nl-NL"/>
           </a:p>
@@ -3150,7 +3150,7 @@
           <a:p>
             <a:fld id="{291A462F-E04C-4E22-938A-A0EF93E33BE5}" type="datetimeFigureOut">
               <a:rPr lang="nl-NL" smtClean="0"/>
-              <a:t>15-5-2025</a:t>
+              <a:t>19-5-2025</a:t>
             </a:fld>
             <a:endParaRPr lang="nl-NL"/>
           </a:p>
@@ -3393,7 +3393,7 @@
           <a:p>
             <a:fld id="{291A462F-E04C-4E22-938A-A0EF93E33BE5}" type="datetimeFigureOut">
               <a:rPr lang="nl-NL" smtClean="0"/>
-              <a:t>15-5-2025</a:t>
+              <a:t>19-5-2025</a:t>
             </a:fld>
             <a:endParaRPr lang="nl-NL"/>
           </a:p>
@@ -12958,7 +12958,9 @@
         </p:nvSpPr>
         <p:spPr/>
         <p:txBody>
-          <a:bodyPr/>
+          <a:bodyPr>
+            <a:normAutofit lnSpcReduction="10000"/>
+          </a:bodyPr>
           <a:lstStyle/>
           <a:p>
             <a:r>
@@ -13176,6 +13178,73 @@
             <a:r>
               <a:rPr lang="nl-NL" dirty="0" err="1"/>
               <a:t>confusingly</a:t>
+            </a:r>
+            <a:endParaRPr lang="nl-NL" dirty="0"/>
+          </a:p>
+          <a:p>
+            <a:r>
+              <a:rPr lang="nl-NL" dirty="0" err="1"/>
+              <a:t>Loaded</a:t>
+            </a:r>
+            <a:r>
+              <a:rPr lang="nl-NL" dirty="0"/>
+              <a:t> </a:t>
+            </a:r>
+            <a:r>
+              <a:rPr lang="nl-NL" dirty="0" err="1"/>
+              <a:t>playlist</a:t>
+            </a:r>
+            <a:r>
+              <a:rPr lang="nl-NL" dirty="0"/>
+              <a:t> </a:t>
+            </a:r>
+            <a:r>
+              <a:rPr lang="nl-NL" dirty="0" err="1"/>
+              <a:t>should</a:t>
+            </a:r>
+            <a:r>
+              <a:rPr lang="nl-NL" dirty="0"/>
+              <a:t> </a:t>
+            </a:r>
+            <a:r>
+              <a:rPr lang="nl-NL" dirty="0" err="1"/>
+              <a:t>be</a:t>
+            </a:r>
+            <a:r>
+              <a:rPr lang="nl-NL" dirty="0"/>
+              <a:t> </a:t>
+            </a:r>
+            <a:r>
+              <a:rPr lang="nl-NL" dirty="0" err="1"/>
+              <a:t>possible</a:t>
+            </a:r>
+            <a:r>
+              <a:rPr lang="nl-NL" dirty="0"/>
+              <a:t> </a:t>
+            </a:r>
+            <a:r>
+              <a:rPr lang="nl-NL" dirty="0" err="1"/>
+              <a:t>to</a:t>
+            </a:r>
+            <a:r>
+              <a:rPr lang="nl-NL" dirty="0"/>
+              <a:t> order: </a:t>
+            </a:r>
+            <a:r>
+              <a:rPr lang="nl-NL" dirty="0" err="1"/>
+              <a:t>normal</a:t>
+            </a:r>
+            <a:r>
+              <a:rPr lang="nl-NL" dirty="0"/>
+              <a:t>, random, </a:t>
+            </a:r>
+            <a:r>
+              <a:rPr lang="nl-NL" dirty="0" err="1"/>
+              <a:t>newest</a:t>
+            </a:r>
+            <a:r>
+              <a:rPr lang="nl-NL"/>
+              <a:t> first</a:t>
             </a:r>
             <a:endParaRPr lang="nl-NL" dirty="0"/>
           </a:p>

</xml_diff>

<commit_message>
bugfixes: buffers not being freed causing memory to explode, trackClock not being set to correct beat when paused, causing silence when combining looping and que
</commit_message>
<xml_diff>
--- a/Design Log/DJ deck.pptx
+++ b/Design Log/DJ deck.pptx
@@ -223,7 +223,7 @@
           <a:p>
             <a:fld id="{F2131A79-E1C2-43E2-88BB-991A587CF34B}" type="datetimeFigureOut">
               <a:rPr lang="nl-NL" smtClean="0"/>
-              <a:t>19-5-2025</a:t>
+              <a:t>12-6-2025</a:t>
             </a:fld>
             <a:endParaRPr lang="nl-NL"/>
           </a:p>
@@ -724,7 +724,7 @@
           <a:p>
             <a:fld id="{291A462F-E04C-4E22-938A-A0EF93E33BE5}" type="datetimeFigureOut">
               <a:rPr lang="nl-NL" smtClean="0"/>
-              <a:t>19-5-2025</a:t>
+              <a:t>12-6-2025</a:t>
             </a:fld>
             <a:endParaRPr lang="nl-NL"/>
           </a:p>
@@ -924,7 +924,7 @@
           <a:p>
             <a:fld id="{291A462F-E04C-4E22-938A-A0EF93E33BE5}" type="datetimeFigureOut">
               <a:rPr lang="nl-NL" smtClean="0"/>
-              <a:t>19-5-2025</a:t>
+              <a:t>12-6-2025</a:t>
             </a:fld>
             <a:endParaRPr lang="nl-NL"/>
           </a:p>
@@ -1134,7 +1134,7 @@
           <a:p>
             <a:fld id="{291A462F-E04C-4E22-938A-A0EF93E33BE5}" type="datetimeFigureOut">
               <a:rPr lang="nl-NL" smtClean="0"/>
-              <a:t>19-5-2025</a:t>
+              <a:t>12-6-2025</a:t>
             </a:fld>
             <a:endParaRPr lang="nl-NL"/>
           </a:p>
@@ -1334,7 +1334,7 @@
           <a:p>
             <a:fld id="{291A462F-E04C-4E22-938A-A0EF93E33BE5}" type="datetimeFigureOut">
               <a:rPr lang="nl-NL" smtClean="0"/>
-              <a:t>19-5-2025</a:t>
+              <a:t>12-6-2025</a:t>
             </a:fld>
             <a:endParaRPr lang="nl-NL"/>
           </a:p>
@@ -1610,7 +1610,7 @@
           <a:p>
             <a:fld id="{291A462F-E04C-4E22-938A-A0EF93E33BE5}" type="datetimeFigureOut">
               <a:rPr lang="nl-NL" smtClean="0"/>
-              <a:t>19-5-2025</a:t>
+              <a:t>12-6-2025</a:t>
             </a:fld>
             <a:endParaRPr lang="nl-NL"/>
           </a:p>
@@ -1878,7 +1878,7 @@
           <a:p>
             <a:fld id="{291A462F-E04C-4E22-938A-A0EF93E33BE5}" type="datetimeFigureOut">
               <a:rPr lang="nl-NL" smtClean="0"/>
-              <a:t>19-5-2025</a:t>
+              <a:t>12-6-2025</a:t>
             </a:fld>
             <a:endParaRPr lang="nl-NL"/>
           </a:p>
@@ -2293,7 +2293,7 @@
           <a:p>
             <a:fld id="{291A462F-E04C-4E22-938A-A0EF93E33BE5}" type="datetimeFigureOut">
               <a:rPr lang="nl-NL" smtClean="0"/>
-              <a:t>19-5-2025</a:t>
+              <a:t>12-6-2025</a:t>
             </a:fld>
             <a:endParaRPr lang="nl-NL"/>
           </a:p>
@@ -2435,7 +2435,7 @@
           <a:p>
             <a:fld id="{291A462F-E04C-4E22-938A-A0EF93E33BE5}" type="datetimeFigureOut">
               <a:rPr lang="nl-NL" smtClean="0"/>
-              <a:t>19-5-2025</a:t>
+              <a:t>12-6-2025</a:t>
             </a:fld>
             <a:endParaRPr lang="nl-NL"/>
           </a:p>
@@ -2548,7 +2548,7 @@
           <a:p>
             <a:fld id="{291A462F-E04C-4E22-938A-A0EF93E33BE5}" type="datetimeFigureOut">
               <a:rPr lang="nl-NL" smtClean="0"/>
-              <a:t>19-5-2025</a:t>
+              <a:t>12-6-2025</a:t>
             </a:fld>
             <a:endParaRPr lang="nl-NL"/>
           </a:p>
@@ -2861,7 +2861,7 @@
           <a:p>
             <a:fld id="{291A462F-E04C-4E22-938A-A0EF93E33BE5}" type="datetimeFigureOut">
               <a:rPr lang="nl-NL" smtClean="0"/>
-              <a:t>19-5-2025</a:t>
+              <a:t>12-6-2025</a:t>
             </a:fld>
             <a:endParaRPr lang="nl-NL"/>
           </a:p>
@@ -3150,7 +3150,7 @@
           <a:p>
             <a:fld id="{291A462F-E04C-4E22-938A-A0EF93E33BE5}" type="datetimeFigureOut">
               <a:rPr lang="nl-NL" smtClean="0"/>
-              <a:t>19-5-2025</a:t>
+              <a:t>12-6-2025</a:t>
             </a:fld>
             <a:endParaRPr lang="nl-NL"/>
           </a:p>
@@ -3393,7 +3393,7 @@
           <a:p>
             <a:fld id="{291A462F-E04C-4E22-938A-A0EF93E33BE5}" type="datetimeFigureOut">
               <a:rPr lang="nl-NL" smtClean="0"/>
-              <a:t>19-5-2025</a:t>
+              <a:t>12-6-2025</a:t>
             </a:fld>
             <a:endParaRPr lang="nl-NL"/>
           </a:p>
@@ -12711,7 +12711,7 @@
             </a:r>
             <a:r>
               <a:rPr lang="nl-NL" dirty="0" err="1"/>
-              <a:t>two</a:t>
+              <a:t>various</a:t>
             </a:r>
             <a:r>
               <a:rPr lang="nl-NL" dirty="0"/>
@@ -12773,49 +12773,261 @@
               <a:t> </a:t>
             </a:r>
             <a:r>
+              <a:rPr lang="nl-NL" dirty="0" err="1"/>
+              <a:t>implemented</a:t>
+            </a:r>
+            <a:endParaRPr lang="nl-NL" dirty="0"/>
+          </a:p>
+          <a:p>
+            <a:pPr lvl="1"/>
+            <a:r>
+              <a:rPr lang="nl-NL" dirty="0"/>
+              <a:t>End, end point of loop is </a:t>
+            </a:r>
+            <a:r>
+              <a:rPr lang="nl-NL" dirty="0" err="1"/>
+              <a:t>fixed</a:t>
+            </a:r>
+            <a:r>
+              <a:rPr lang="nl-NL" dirty="0"/>
+              <a:t>, </a:t>
+            </a:r>
+            <a:r>
+              <a:rPr lang="nl-NL" dirty="0" err="1"/>
+              <a:t>length</a:t>
+            </a:r>
+            <a:r>
+              <a:rPr lang="nl-NL" dirty="0"/>
+              <a:t> </a:t>
+            </a:r>
+            <a:r>
+              <a:rPr lang="nl-NL" dirty="0" err="1"/>
+              <a:t>modulates</a:t>
+            </a:r>
+            <a:r>
+              <a:rPr lang="nl-NL" dirty="0"/>
+              <a:t> </a:t>
+            </a:r>
+            <a:r>
+              <a:rPr lang="nl-NL" dirty="0" err="1"/>
+              <a:t>the</a:t>
+            </a:r>
+            <a:r>
+              <a:rPr lang="nl-NL" dirty="0"/>
+              <a:t> start point</a:t>
+            </a:r>
+          </a:p>
+          <a:p>
+            <a:pPr lvl="1"/>
+            <a:r>
+              <a:rPr lang="nl-NL" dirty="0"/>
+              <a:t>Automatic, </a:t>
+            </a:r>
+            <a:r>
+              <a:rPr lang="nl-NL" dirty="0" err="1"/>
+              <a:t>it</a:t>
+            </a:r>
+            <a:r>
+              <a:rPr lang="nl-NL" dirty="0"/>
+              <a:t> </a:t>
+            </a:r>
+            <a:r>
+              <a:rPr lang="nl-NL" dirty="0" err="1"/>
+              <a:t>quantizes</a:t>
+            </a:r>
+            <a:r>
+              <a:rPr lang="nl-NL" dirty="0"/>
+              <a:t> </a:t>
+            </a:r>
+            <a:r>
+              <a:rPr lang="nl-NL" dirty="0" err="1"/>
+              <a:t>the</a:t>
+            </a:r>
+            <a:r>
+              <a:rPr lang="nl-NL" dirty="0"/>
+              <a:t> loop a new </a:t>
+            </a:r>
+            <a:r>
+              <a:rPr lang="nl-NL" dirty="0" err="1"/>
+              <a:t>each</a:t>
+            </a:r>
+            <a:r>
+              <a:rPr lang="nl-NL" dirty="0"/>
+              <a:t> time </a:t>
+            </a:r>
+            <a:r>
+              <a:rPr lang="nl-NL" dirty="0" err="1"/>
+              <a:t>you</a:t>
+            </a:r>
+            <a:r>
+              <a:rPr lang="nl-NL" dirty="0"/>
+              <a:t> change </a:t>
+            </a:r>
+            <a:r>
+              <a:rPr lang="nl-NL" dirty="0" err="1"/>
+              <a:t>the</a:t>
+            </a:r>
+            <a:r>
+              <a:rPr lang="nl-NL" dirty="0"/>
+              <a:t> </a:t>
+            </a:r>
+            <a:r>
+              <a:rPr lang="nl-NL" dirty="0" err="1"/>
+              <a:t>length</a:t>
+            </a:r>
+            <a:r>
+              <a:rPr lang="nl-NL" dirty="0"/>
+              <a:t>, </a:t>
+            </a:r>
+            <a:r>
+              <a:rPr lang="nl-NL" dirty="0" err="1"/>
+              <a:t>so</a:t>
+            </a:r>
+            <a:r>
+              <a:rPr lang="nl-NL" dirty="0"/>
+              <a:t> </a:t>
+            </a:r>
+            <a:r>
+              <a:rPr lang="nl-NL" dirty="0" err="1"/>
+              <a:t>if</a:t>
+            </a:r>
+            <a:r>
+              <a:rPr lang="nl-NL" dirty="0"/>
+              <a:t> </a:t>
+            </a:r>
+            <a:r>
+              <a:rPr lang="nl-NL" dirty="0" err="1"/>
+              <a:t>you</a:t>
+            </a:r>
+            <a:r>
+              <a:rPr lang="nl-NL" dirty="0"/>
+              <a:t> are </a:t>
+            </a:r>
+            <a:r>
+              <a:rPr lang="nl-NL" dirty="0" err="1"/>
+              <a:t>doing</a:t>
+            </a:r>
+            <a:r>
+              <a:rPr lang="nl-NL" dirty="0"/>
+              <a:t> a 2 beat loop, loop beat 3 </a:t>
+            </a:r>
+            <a:r>
+              <a:rPr lang="nl-NL" dirty="0" err="1"/>
+              <a:t>and</a:t>
+            </a:r>
+            <a:r>
+              <a:rPr lang="nl-NL" dirty="0"/>
+              <a:t> 4, </a:t>
+            </a:r>
+            <a:r>
+              <a:rPr lang="nl-NL" dirty="0" err="1"/>
+              <a:t>and</a:t>
+            </a:r>
+            <a:r>
+              <a:rPr lang="nl-NL" dirty="0"/>
+              <a:t> </a:t>
+            </a:r>
+            <a:r>
+              <a:rPr lang="nl-NL" dirty="0" err="1"/>
+              <a:t>you</a:t>
+            </a:r>
+            <a:r>
+              <a:rPr lang="nl-NL" dirty="0"/>
+              <a:t> change </a:t>
+            </a:r>
+            <a:r>
+              <a:rPr lang="nl-NL" dirty="0" err="1"/>
+              <a:t>to</a:t>
+            </a:r>
+            <a:r>
+              <a:rPr lang="nl-NL" dirty="0"/>
+              <a:t> </a:t>
+            </a:r>
+            <a:r>
+              <a:rPr lang="nl-NL" dirty="0" err="1"/>
+              <a:t>an</a:t>
+            </a:r>
+            <a:r>
+              <a:rPr lang="nl-NL" dirty="0"/>
+              <a:t> 8 beat loop </a:t>
+            </a:r>
+            <a:r>
+              <a:rPr lang="nl-NL" dirty="0" err="1"/>
+              <a:t>it</a:t>
+            </a:r>
+            <a:r>
+              <a:rPr lang="nl-NL" dirty="0"/>
+              <a:t> </a:t>
+            </a:r>
+            <a:r>
+              <a:rPr lang="nl-NL" dirty="0" err="1"/>
+              <a:t>will</a:t>
+            </a:r>
+            <a:r>
+              <a:rPr lang="nl-NL" dirty="0"/>
+              <a:t> loop </a:t>
+            </a:r>
+            <a:r>
+              <a:rPr lang="nl-NL" dirty="0" err="1"/>
+              <a:t>from</a:t>
+            </a:r>
+            <a:r>
+              <a:rPr lang="nl-NL" dirty="0"/>
+              <a:t> 1 </a:t>
+            </a:r>
+            <a:r>
+              <a:rPr lang="nl-NL" dirty="0" err="1"/>
+              <a:t>to</a:t>
+            </a:r>
+            <a:r>
+              <a:rPr lang="nl-NL" dirty="0"/>
+              <a:t> 8, </a:t>
+            </a:r>
+            <a:r>
+              <a:rPr lang="nl-NL" dirty="0" err="1"/>
+              <a:t>thereby</a:t>
+            </a:r>
+            <a:r>
+              <a:rPr lang="nl-NL" dirty="0"/>
+              <a:t> </a:t>
+            </a:r>
+            <a:r>
+              <a:rPr lang="nl-NL" dirty="0" err="1"/>
+              <a:t>modifying</a:t>
+            </a:r>
+            <a:r>
+              <a:rPr lang="nl-NL" dirty="0"/>
+              <a:t> </a:t>
+            </a:r>
+            <a:r>
+              <a:rPr lang="nl-NL" dirty="0" err="1"/>
+              <a:t>both</a:t>
+            </a:r>
+            <a:r>
+              <a:rPr lang="nl-NL" dirty="0"/>
+              <a:t> </a:t>
+            </a:r>
+            <a:r>
+              <a:rPr lang="nl-NL" dirty="0" err="1"/>
+              <a:t>the</a:t>
+            </a:r>
+            <a:r>
+              <a:rPr lang="nl-NL" dirty="0"/>
+              <a:t> start </a:t>
+            </a:r>
+            <a:r>
+              <a:rPr lang="nl-NL" dirty="0" err="1"/>
+              <a:t>and</a:t>
+            </a:r>
+            <a:r>
+              <a:rPr lang="nl-NL" dirty="0"/>
+              <a:t> </a:t>
+            </a:r>
+            <a:r>
               <a:rPr lang="nl-NL"/>
-              <a:t>implemented</a:t>
+              <a:t>end point</a:t>
             </a:r>
             <a:endParaRPr lang="nl-NL" dirty="0"/>
-          </a:p>
-          <a:p>
-            <a:pPr lvl="1"/>
-            <a:r>
-              <a:rPr lang="nl-NL" dirty="0"/>
-              <a:t>End, end point of loop is </a:t>
-            </a:r>
-            <a:r>
-              <a:rPr lang="nl-NL" dirty="0" err="1"/>
-              <a:t>fixed</a:t>
-            </a:r>
-            <a:r>
-              <a:rPr lang="nl-NL" dirty="0"/>
-              <a:t>, </a:t>
-            </a:r>
-            <a:r>
-              <a:rPr lang="nl-NL" dirty="0" err="1"/>
-              <a:t>length</a:t>
-            </a:r>
-            <a:r>
-              <a:rPr lang="nl-NL" dirty="0"/>
-              <a:t> </a:t>
-            </a:r>
-            <a:r>
-              <a:rPr lang="nl-NL" dirty="0" err="1"/>
-              <a:t>modulates</a:t>
-            </a:r>
-            <a:r>
-              <a:rPr lang="nl-NL" dirty="0"/>
-              <a:t> </a:t>
-            </a:r>
-            <a:r>
-              <a:rPr lang="nl-NL" dirty="0" err="1"/>
-              <a:t>the</a:t>
-            </a:r>
-            <a:r>
-              <a:rPr lang="nl-NL" dirty="0"/>
-              <a:t> start point</a:t>
-            </a:r>
           </a:p>
         </p:txBody>
       </p:sp>

</xml_diff>